<commit_message>
References: complete the four author-less entries, one by replacement
[7], [10] and [11] completed with full author lists, venues and DOIs from
Crossref: Kim et al. (IMC 2025, pp. 541-557), Khanna and Kotwal (Discover
Public Health 22:381, 2025), Sood et al. (npj Digital Medicine 8:48, 2025).

[9] -- "A Critical Review of Health Data Interoperability Standards" --
exists only as a repository upload with no journal, DOI or accessible
author list, so it cannot be verified and is replaced by Vorisek et al.,
"FHIR for Interoperability in Health Research: Systematic Review," JMIR
Medical Informatics 10(7):e35724, 2022, which serves the same role in the
argument. Chapter 2's three uses of [9] are reworded to match what the
replacement actually covers. Deck rebuilt; outline and PLAN updated.
All sixteen entries are now verifiable.

Co-Authored-By: Claude Opus 5 <noreply@anthropic.com>
</commit_message>
<xml_diff>
--- a/Review-II.pptx
+++ b/Review-II.pptx
@@ -2436,7 +2436,7 @@
                 <a:ea typeface="Calibri" pitchFamily="34" charset="-122"/>
                 <a:cs typeface="Calibri" pitchFamily="34" charset="-120"/>
               </a:rPr>
-              <a:t>[7] "Scrapers Selectively Respect robots.txt Directives: Evidence From a Large-Scale Empirical Study," in Proc. 2025 ACM Internet Measurement Conf. (IMC), 2025.</a:t>
+              <a:t>[7] T. Kim, K. Bock, C. Luo, A. Liswood, C. Poroslay, and E. Wenger, "Scrapers Selectively Respect robots.txt Directives: Evidence From a Large-Scale Empirical Study," in Proc. 2025 ACM Internet Measurement Conf. (IMC), Madison, WI, USA, 2025, pp. 541–557, doi:10.1145/3730567.3764471.</a:t>
             </a:r>
             <a:endParaRPr lang="en-US" sz="1600" dirty="0"/>
           </a:p>
@@ -2478,7 +2478,7 @@
                 <a:ea typeface="Calibri" pitchFamily="34" charset="-122"/>
                 <a:cs typeface="Calibri" pitchFamily="34" charset="-120"/>
               </a:rPr>
-              <a:t>[9] "A Critical Review of Health Data Interoperability Standards: FHIR, HL7, and Beyond," 2025.</a:t>
+              <a:t>[9] C. N. Vorisek, M. Lehne, S. A. I. Klopfenstein, P. J. Mayer, A. Bartschke, T. Haese, and S. Thun, "Fast Healthcare Interoperability Resources (FHIR) for Interoperability in Health Research: Systematic Review," JMIR Medical Informatics, vol. 10, no. 7, art. e35724, 2022, doi:10.2196/35724.</a:t>
             </a:r>
             <a:endParaRPr lang="en-US" sz="1600" dirty="0"/>
           </a:p>
@@ -2499,7 +2499,7 @@
                 <a:ea typeface="Calibri" pitchFamily="34" charset="-122"/>
                 <a:cs typeface="Calibri" pitchFamily="34" charset="-120"/>
               </a:rPr>
-              <a:t>[10] "Examining the Significance of the Digital Personal Data Protection Act, 2023 in the Context of the Healthcare Industry: A Comprehensive Analysis," Discover Public Health, 2025.</a:t>
+              <a:t>[10] V. Khanna and A. Kotwal, "Examining the Significance of the Digital Personal Data Protection Act, 2023 in the Context of the Healthcare Industry: A Comprehensive Analysis," Discover Public Health, vol. 22, art. 381, 2025, doi:10.1186/s12982-025-00757-6.</a:t>
             </a:r>
             <a:endParaRPr lang="en-US" sz="1600" dirty="0"/>
           </a:p>
@@ -2520,7 +2520,7 @@
                 <a:ea typeface="Calibri" pitchFamily="34" charset="-122"/>
                 <a:cs typeface="Calibri" pitchFamily="34" charset="-120"/>
               </a:rPr>
-              <a:t>[11] "Challenges and Recommendations for Enhancing Digital Data Protection in the Indian Medical Research and Healthcare Sector," npj Digital Medicine, 2025.</a:t>
+              <a:t>[11] A. Sood, D. Mishra, V. Surya, H. Singh, R. Sundaresan, D. Pal, R. Dharmaraju, R. Satish, S. Mishra, N. A. Chavan, S. Mondal, P. Duggal, and V. K. Iyer, "Challenges and Recommendations for Enhancing Digital Data Protection in the Indian Medical Research and Healthcare Sector," npj Digital Medicine, vol. 8, art. 48, 2025, doi:10.1038/s41746-025-01448-x.</a:t>
             </a:r>
             <a:endParaRPr lang="en-US" sz="1600" dirty="0"/>
           </a:p>
@@ -3715,7 +3715,7 @@
                     <a:p>
                       <a:r>
                         <a:rPr sz="1150"/>
-                        <a:t>ACM IMC, 2025</a:t>
+                        <a:t>Kim et al., 2025</a:t>
                       </a:r>
                     </a:p>
                   </a:txBody>
@@ -3765,7 +3765,7 @@
                     <a:p>
                       <a:r>
                         <a:rPr sz="1150"/>
-                        <a:t>Scrapers Selectively Respect robots.txt Directives — large-scale study</a:t>
+                        <a:t>Scrapers Selectively Respect robots.txt Directives — ACM IMC</a:t>
                       </a:r>
                     </a:p>
                   </a:txBody>
@@ -4259,7 +4259,7 @@
                     <a:p>
                       <a:r>
                         <a:rPr sz="1150"/>
-                        <a:t>Interoperability review, 2025</a:t>
+                        <a:t>Vorisek et al., 2022</a:t>
                       </a:r>
                     </a:p>
                   </a:txBody>
@@ -4309,7 +4309,7 @@
                     <a:p>
                       <a:r>
                         <a:rPr sz="1150"/>
-                        <a:t>A Critical Review of Health Data Interoperability Standards: FHIR, HL7 and Beyond</a:t>
+                        <a:t>FHIR for Interoperability in Health Research: Systematic Review — JMIR Med. Inform.</a:t>
                       </a:r>
                     </a:p>
                   </a:txBody>
@@ -4359,7 +4359,7 @@
                     <a:p>
                       <a:r>
                         <a:rPr sz="1150"/>
-                        <a:t>Critical review of HL7 / FHIR and related standards</a:t>
+                        <a:t>49 studies on FHIR use cases, implementation, goals and limitations in research</a:t>
                       </a:r>
                     </a:p>
                   </a:txBody>
@@ -4531,7 +4531,7 @@
                     <a:p>
                       <a:r>
                         <a:rPr sz="1150"/>
-                        <a:t>Discover Public Health, 2025</a:t>
+                        <a:t>Khanna &amp; Kotwal, 2025</a:t>
                       </a:r>
                     </a:p>
                   </a:txBody>
@@ -4581,7 +4581,7 @@
                     <a:p>
                       <a:r>
                         <a:rPr sz="1150"/>
-                        <a:t>Significance of the DPDP Act 2023 for the Healthcare Industry</a:t>
+                        <a:t>Significance of the DPDP Act 2023 for the Healthcare Industry — Discover Public Health</a:t>
                       </a:r>
                     </a:p>
                   </a:txBody>
@@ -5624,7 +5624,7 @@
                     <a:p>
                       <a:r>
                         <a:rPr sz="1150"/>
-                        <a:t>npj Digital Medicine, 2025</a:t>
+                        <a:t>Sood et al., 2025</a:t>
                       </a:r>
                     </a:p>
                   </a:txBody>
@@ -5674,7 +5674,7 @@
                     <a:p>
                       <a:r>
                         <a:rPr sz="1150"/>
-                        <a:t>Digital Data Protection in Indian Medical Research and Healthcare</a:t>
+                        <a:t>Digital Data Protection in Indian Medical Research and Healthcare — npj Digital Medicine</a:t>
                       </a:r>
                     </a:p>
                   </a:txBody>

</xml_diff>

<commit_message>
Deck: results slide numbers match the demo's default run (20 records; 70 / 330 page loads)
Co-Authored-By: Claude Opus 5 <noreply@anthropic.com>
</commit_message>
<xml_diff>
--- a/Review-II.pptx
+++ b/Review-II.pptx
@@ -13612,7 +13612,7 @@
                 </a:solidFill>
                 <a:latin typeface="Calibri"/>
               </a:rPr>
-              <a:t>Three techniques, three extraction tasks, the same login-gated portal scraped by a real browser (30 records per module); every run scored on the identical seven rules; cost measured as real page loads. The techniques differ only in how they treat personal data.</a:t>
+              <a:t>Three techniques, three extraction tasks, the same login-gated portal scraped by a real browser (20 records per module, 10 per page); every run scored on the identical seven rules; cost measured as real page loads. The techniques differ only in how they treat personal data.</a:t>
             </a:r>
           </a:p>
         </p:txBody>
@@ -13788,7 +13788,7 @@
                           </a:solidFill>
                           <a:latin typeface="Calibri"/>
                         </a:rPr>
-                        <a:t>1.00 · 1.00 · ~100</a:t>
+                        <a:t>1.00 · 1.00 · 70</a:t>
                       </a:r>
                     </a:p>
                   </a:txBody>
@@ -13878,7 +13878,7 @@
                           </a:solidFill>
                           <a:latin typeface="Calibri"/>
                         </a:rPr>
-                        <a:t>0.85 · 0.85 · ~100</a:t>
+                        <a:t>0.85 · 0.85 · 70</a:t>
                       </a:r>
                     </a:p>
                   </a:txBody>
@@ -13968,7 +13968,7 @@
                           </a:solidFill>
                           <a:latin typeface="Calibri"/>
                         </a:rPr>
-                        <a:t>7.15 · 1.00 · ~480</a:t>
+                        <a:t>7.15 · 1.00 · 330</a:t>
                       </a:r>
                     </a:p>
                   </a:txBody>

</xml_diff>

<commit_message>
Docs and deck follow the AI-agent comparison
CLAUDE.md records the guide's direction and the three properties that must
keep holding; PLAN reverses W7 with its reason and states what "done" now
means (recordings for at least one provider, both briefings); DEMO_GUIDE,
README and the presenter flow describe the agents, the recordings and the
stable column in place of the morality model. The deck's results slide now
reads its rows from benchmark-portal.json so it cannot drift from what the
demo prints; tracked artefacts regenerated -- ours against the baseline
until recordings exist, and every demo says so. Report chapters 4 and 7
carry a revision-pending note rather than rewritten numbers: those come
from real recordings, not a dry run.

Co-Authored-By: Claude Opus 5 <noreply@anthropic.com>
</commit_message>
<xml_diff>
--- a/Review-II.pptx
+++ b/Review-II.pptx
@@ -9658,7 +9658,7 @@
                 <a:ea typeface="Calibri" pitchFamily="34" charset="-122"/>
                 <a:cs typeface="Calibri" pitchFamily="34" charset="-120"/>
               </a:rPr>
-              <a:t>The middle technique is now the morality model — privacy judged by instinct from a field's name, no concept of purpose — deliberately not DPDP-compliant; the hand-written baseline stands, as the panel agreed most deployed systems sit there.</a:t>
+              <a:t>The comparison is now ours against publicly available AI agents (Claude, GPT, Gemini), each briefed with the job, the purpose and the field names — never a value — unaided and told the Act; decisions recorded, replayed, and repeated so determinism is a measured column. The hand-written baseline stands, as the panel agreed most deployed systems sit there.</a:t>
             </a:r>
             <a:endParaRPr lang="en-US" sz="1500" dirty="0"/>
           </a:p>
@@ -13280,7 +13280,7 @@
                 <a:ea typeface="Calibri" pitchFamily="34" charset="-122"/>
                 <a:cs typeface="Calibri" pitchFamily="34" charset="-120"/>
               </a:rPr>
-              <a:t>extraction/ — HISDataSource interface; adapters mock / portal (Playwright) / dataset (pandas, column map); techniques compliant / morality / unconstrained; metering; tier2 browser + navigation discovery.</a:t>
+              <a:t>extraction/ — HISDataSource interface; adapters mock / portal (Playwright) / dataset (pandas, column map); techniques compliant / ai_agent (Claude, OpenAI, Gemini; record + replay) / unconstrained; metering incl. determinism; tier2 browser + navigation discovery.</a:t>
             </a:r>
             <a:endParaRPr lang="en-US" sz="1500" dirty="0"/>
           </a:p>
@@ -13612,7 +13612,7 @@
                 </a:solidFill>
                 <a:latin typeface="Calibri"/>
               </a:rPr>
-              <a:t>Three techniques, three extraction tasks, the same login-gated portal scraped by a real browser (20 records per module, 10 per page); every run scored on the identical seven rules; cost measured as real page loads. The techniques differ only in how they treat personal data.</a:t>
+              <a:t>2 techniques, 3 extraction tasks, the same login-gated portal scraped by a real browser (20 records per module, 10 per page); every run scored on the identical seven rules; cost measured as real page loads. The techniques differ only in how they treat personal data.</a:t>
             </a:r>
           </a:p>
         </p:txBody>
@@ -13641,7 +13641,7 @@
                 <a:gridCol w="2377440"/>
                 <a:gridCol w="4142232"/>
               </a:tblGrid>
-              <a:tr h="582930">
+              <a:tr h="777240">
                 <a:tc>
                   <a:txBody>
                     <a:bodyPr/>
@@ -13731,7 +13731,7 @@
                   </a:tcPr>
                 </a:tc>
               </a:tr>
-              <a:tr h="582930">
+              <a:tr h="777240">
                 <a:tc>
                   <a:txBody>
                     <a:bodyPr/>
@@ -13766,7 +13766,7 @@
                           </a:solidFill>
                           <a:latin typeface="Calibri"/>
                         </a:rPr>
-                        <a:t>1.000  ·  7 / 7 rules</a:t>
+                        <a:t>1.000  ·  7/7 rules</a:t>
                       </a:r>
                     </a:p>
                   </a:txBody>
@@ -13821,97 +13821,7 @@
                   </a:tcPr>
                 </a:tc>
               </a:tr>
-              <a:tr h="582930">
-                <a:tc>
-                  <a:txBody>
-                    <a:bodyPr/>
-                    <a:lstStyle/>
-                    <a:p>
-                      <a:r>
-                        <a:rPr sz="1150" b="0">
-                          <a:solidFill>
-                            <a:srgbClr val="000000"/>
-                          </a:solidFill>
-                          <a:latin typeface="Calibri"/>
-                        </a:rPr>
-                        <a:t>morality (privacy by instinct)</a:t>
-                      </a:r>
-                    </a:p>
-                  </a:txBody>
-                  <a:tcPr>
-                    <a:solidFill>
-                      <a:srgbClr val="FFFFFF"/>
-                    </a:solidFill>
-                  </a:tcPr>
-                </a:tc>
-                <a:tc>
-                  <a:txBody>
-                    <a:bodyPr/>
-                    <a:lstStyle/>
-                    <a:p>
-                      <a:r>
-                        <a:rPr sz="1150" b="0">
-                          <a:solidFill>
-                            <a:srgbClr val="000000"/>
-                          </a:solidFill>
-                          <a:latin typeface="Calibri"/>
-                        </a:rPr>
-                        <a:t>0.484  ·  2 / 7 rules</a:t>
-                      </a:r>
-                    </a:p>
-                  </a:txBody>
-                  <a:tcPr>
-                    <a:solidFill>
-                      <a:srgbClr val="FFFFFF"/>
-                    </a:solidFill>
-                  </a:tcPr>
-                </a:tc>
-                <a:tc>
-                  <a:txBody>
-                    <a:bodyPr/>
-                    <a:lstStyle/>
-                    <a:p>
-                      <a:r>
-                        <a:rPr sz="1150" b="0">
-                          <a:solidFill>
-                            <a:srgbClr val="000000"/>
-                          </a:solidFill>
-                          <a:latin typeface="Calibri"/>
-                        </a:rPr>
-                        <a:t>0.85 · 0.85 · 70</a:t>
-                      </a:r>
-                    </a:p>
-                  </a:txBody>
-                  <a:tcPr>
-                    <a:solidFill>
-                      <a:srgbClr val="FFFFFF"/>
-                    </a:solidFill>
-                  </a:tcPr>
-                </a:tc>
-                <a:tc>
-                  <a:txBody>
-                    <a:bodyPr/>
-                    <a:lstStyle/>
-                    <a:p>
-                      <a:r>
-                        <a:rPr sz="1150" b="0">
-                          <a:solidFill>
-                            <a:srgbClr val="000000"/>
-                          </a:solidFill>
-                          <a:latin typeface="Calibri"/>
-                        </a:rPr>
-                        <a:t>Refuses what feels private (names, contact, money) whatever the purpose; takes MRN and DOB freely; consent assumed, no notice, no retention.</a:t>
-                      </a:r>
-                    </a:p>
-                  </a:txBody>
-                  <a:tcPr>
-                    <a:solidFill>
-                      <a:srgbClr val="FFFFFF"/>
-                    </a:solidFill>
-                  </a:tcPr>
-                </a:tc>
-              </a:tr>
-              <a:tr h="582930">
+              <a:tr h="777240">
                 <a:tc>
                   <a:txBody>
                     <a:bodyPr/>
@@ -13946,7 +13856,7 @@
                           </a:solidFill>
                           <a:latin typeface="Calibri"/>
                         </a:rPr>
-                        <a:t>0.135  ·  0 / 7 rules</a:t>
+                        <a:t>0.135  ·  0/7 rules</a:t>
                       </a:r>
                     </a:p>
                   </a:txBody>
@@ -14045,7 +13955,7 @@
                 </a:solidFill>
                 <a:latin typeface="Calibri"/>
               </a:rPr>
-              <a:t>The morality model is the cheapest — and the cheapness is its failure: coverage 0.85 because it refused a name and a phone number an appointment reminder lawfully needs under the registration purpose. Privacy by instinct fails in both directions; only a purpose-bound technique gets both right. Per-rule columns (DM, LB, SL, SS, PL, NT, AC) are in docs/benchmark_results/benchmark-portal.md.</a:t>
+              <a:t>The AI agents are real public models briefed with field names, never values, once unaided and once told the Act; coverage catches any that left out data the job lawfully needs. Repeated runs give a stable column: ours reproduces its decision every time — rules, not sampling; an agent's compliance is a sample. Per-rule columns are in docs/benchmark_results/benchmark-portal.md.</a:t>
             </a:r>
           </a:p>
         </p:txBody>

</xml_diff>

<commit_message>
Review-II deck rebuilt with a live-demonstration slide for the interactive pages
Slide 10, after Implementation where the talk goes live, carries a picture of
each demo page in the state worth pointing at -- the crawl finished (32 / 35 /
440), the billing trap on one Synthea patient, reception's refusal with its
three checks, the rules-vs-AI radar -- with captions and the index path, so
the pictures are there if the room's browser is not.

tools/capture_demo_pages.py drives each page in headless Chromium and writes
docs/review/img/*.png; the deck builder places them and leaves the slide out
if they are missing. The rehearsal and Challenges slides now include the
public-export run (five more defects, each fixed and tested); Implementation
notes text values, stacked per-concept files and the demo pages. Rebuild
order recorded in the Review-II flow and CLAUDE.md: pages, capture, deck.

Co-Authored-By: Claude Opus 5.5 <noreply@anthropic.com>
</commit_message>
<xml_diff>
--- a/Review-II.pptx
+++ b/Review-II.pptx
@@ -17,6 +17,7 @@
     <p:sldId id="269" r:id="rId20"/>
     <p:sldId id="261" r:id="rId7"/>
     <p:sldId id="262" r:id="rId8"/>
+    <p:sldId id="272" r:id="rId23"/>
     <p:sldId id="263" r:id="rId9"/>
     <p:sldId id="264" r:id="rId10"/>
     <p:sldId id="270" r:id="rId21"/>
@@ -1880,7 +1881,7 @@
                 <a:ea typeface="Calibri" pitchFamily="34" charset="-122"/>
                 <a:cs typeface="Calibri" pitchFamily="34" charset="-120"/>
               </a:rPr>
-              <a:t>14</a:t>
+              <a:t>15</a:t>
             </a:r>
             <a:endParaRPr lang="en-US" sz="1000" dirty="0"/>
           </a:p>
@@ -2049,7 +2050,7 @@
                 <a:ea typeface="Calibri" pitchFamily="34" charset="-122"/>
                 <a:cs typeface="Calibri" pitchFamily="34" charset="-120"/>
               </a:rPr>
-              <a:t>Trusting our own claims — the manifest is scored against what the run produced (export audit, observed transport, harness-written audit log, retention sidecar), not against the declaration; and the real-data procedure was rehearsed on a hospital-shaped export before any real data existed, which found four defects.</a:t>
+              <a:t>Trusting our own claims — the manifest is scored against what the run produced (export audit, observed transport, harness-written audit log, retention sidecar), not against the declaration; and the real-data procedure was rehearsed on a hospital-shaped export before any real data existed (four defects found), then run on a public export we had never seen (five more) — each fixed and pinned by a test.</a:t>
             </a:r>
             <a:endParaRPr lang="en-US" sz="1500" dirty="0"/>
           </a:p>
@@ -2226,7 +2227,7 @@
                 <a:ea typeface="Calibri" pitchFamily="34" charset="-122"/>
                 <a:cs typeface="Calibri" pitchFamily="34" charset="-120"/>
               </a:rPr>
-              <a:t>15</a:t>
+              <a:t>16</a:t>
             </a:r>
             <a:endParaRPr lang="en-US" sz="1000" dirty="0"/>
           </a:p>
@@ -2758,7 +2759,7 @@
                 <a:ea typeface="Calibri" pitchFamily="34" charset="-122"/>
                 <a:cs typeface="Calibri" pitchFamily="34" charset="-120"/>
               </a:rPr>
-              <a:t>16</a:t>
+              <a:t>17</a:t>
             </a:r>
             <a:endParaRPr lang="en-US" sz="1000" dirty="0"/>
           </a:p>
@@ -7279,7 +7280,7 @@
                 <a:ea typeface="Calibri" pitchFamily="34" charset="-122"/>
                 <a:cs typeface="Calibri" pitchFamily="34" charset="-120"/>
               </a:rPr>
-              <a:t>12</a:t>
+              <a:t>13</a:t>
             </a:r>
             <a:endParaRPr lang="en-US" sz="1000" dirty="0"/>
           </a:p>
@@ -8212,7 +8213,7 @@
                 <a:ea typeface="Calibri" pitchFamily="34" charset="-122"/>
                 <a:cs typeface="Calibri" pitchFamily="34" charset="-120"/>
               </a:rPr>
-              <a:t>13</a:t>
+              <a:t>14</a:t>
             </a:r>
             <a:endParaRPr lang="en-US" sz="1000" dirty="0"/>
           </a:p>
@@ -8910,7 +8911,7 @@
                 </a:solidFill>
                 <a:latin typeface="Calibri"/>
               </a:rPr>
-              <a:t>The rehearsal found four defects before any real data existed — a header meaning different fields in different files, a split table read half, day-first dates reaching HL7 unparsed, .xlsx unreadable — and each is now fixed and tested. Then everything printed or written was searched for one patient's record number, name and phone: nothing. A recording is a property of the model, not of a source, so no agent is re-recorded for the real data; the day it arrives this slide is rebuilt from its run and nothing else changes.</a:t>
+              <a:t>The rehearsal found four defects before any real data existed — a header meaning different fields in different files, a split table read half, day-first dates reaching HL7 unparsed, .xlsx unreadable — and each is now fixed and tested. Then everything printed or written was searched for one patient's record number, name and phone: nothing. A public export we had never seen (Synthea: 18 files, one per clinical concept) found five more — identifiers read as numbers, a blanked column counted against a file, an empty source still benchmarked, one table kept per layer, a coverage ceiling set by the wrong technique — all fixed and tested. No agent is re-recorded for the real data: the day it arrives this slide is rebuilt from its run and nothing else changes.</a:t>
             </a:r>
           </a:p>
         </p:txBody>
@@ -8944,7 +8945,461 @@
                 </a:solidFill>
                 <a:latin typeface="Calibri"/>
               </a:rPr>
-              <a:t>benchmark-dataset.json, generated 2026-09-21; four tasks; the baseline's records-read column is every patient's records for one patient's task.</a:t>
+              <a:t>benchmark-dataset.json, generated 2026-09-23; four tasks; the baseline's records-read column is every patient's records for one patient's task.</a:t>
+            </a:r>
+          </a:p>
+        </p:txBody>
+      </p:sp>
+    </p:spTree>
+  </p:cSld>
+  <p:clrMapOvr>
+    <a:masterClrMapping/>
+  </p:clrMapOvr>
+</p:sld>
+</file>
+
+<file path=ppt/slides/slide17.xml><?xml version="1.0" encoding="utf-8"?>
+<p:sld xmlns:a="http://schemas.openxmlformats.org/drawingml/2006/main" xmlns:p="http://schemas.openxmlformats.org/presentationml/2006/main" xmlns:r="http://schemas.openxmlformats.org/officeDocument/2006/relationships">
+  <p:cSld>
+    <p:spTree>
+      <p:nvGrpSpPr>
+        <p:cNvPr id="1" name=""/>
+        <p:cNvGrpSpPr/>
+        <p:nvPr/>
+      </p:nvGrpSpPr>
+      <p:grpSpPr/>
+      <p:sp>
+        <p:nvSpPr>
+          <p:cNvPr id="2" name="Text 0"/>
+          <p:cNvSpPr txBox="1"/>
+          <p:nvPr/>
+        </p:nvSpPr>
+        <p:spPr>
+          <a:xfrm>
+            <a:off x="11460175" y="6446520"/>
+            <a:ext cx="457200" cy="274320"/>
+          </a:xfrm>
+          <a:prstGeom prst="rect">
+            <a:avLst/>
+          </a:prstGeom>
+          <a:noFill/>
+          <a:ln/>
+        </p:spPr>
+        <p:txBody>
+          <a:bodyPr wrap="square" lIns="0" tIns="0" rIns="0" bIns="0" rtlCol="0" anchor="ctr"/>
+          <a:lstStyle/>
+          <a:p>
+            <a:pPr marL="0" indent="0" algn="r">
+              <a:buNone/>
+            </a:pPr>
+            <a:r>
+              <a:rPr lang="en-US" sz="1000" dirty="0">
+                <a:solidFill>
+                  <a:srgbClr val="808080"/>
+                </a:solidFill>
+                <a:latin typeface="Calibri" pitchFamily="34" charset="0"/>
+                <a:ea typeface="Calibri" pitchFamily="34" charset="-122"/>
+                <a:cs typeface="Calibri" pitchFamily="34" charset="-120"/>
+              </a:rPr>
+              <a:t>10</a:t>
+            </a:r>
+            <a:endParaRPr lang="en-US" sz="1000" dirty="0"/>
+          </a:p>
+        </p:txBody>
+      </p:sp>
+      <p:sp>
+        <p:nvSpPr>
+          <p:cNvPr id="3" name="Text 1"/>
+          <p:cNvSpPr txBox="1"/>
+          <p:nvPr/>
+        </p:nvSpPr>
+        <p:spPr>
+          <a:xfrm>
+            <a:off x="548640" y="320040"/>
+            <a:ext cx="9601200" cy="685800"/>
+          </a:xfrm>
+          <a:prstGeom prst="rect">
+            <a:avLst/>
+          </a:prstGeom>
+          <a:noFill/>
+          <a:ln/>
+        </p:spPr>
+        <p:txBody>
+          <a:bodyPr wrap="square" lIns="0" tIns="0" rIns="0" bIns="0" rtlCol="0" anchor="ctr"/>
+          <a:lstStyle/>
+          <a:p>
+            <a:pPr marL="0" indent="0">
+              <a:buNone/>
+            </a:pPr>
+            <a:r>
+              <a:rPr lang="en-US" sz="2800" b="1" dirty="0">
+                <a:solidFill>
+                  <a:srgbClr val="1D2F82"/>
+                </a:solidFill>
+                <a:latin typeface="Calibri" pitchFamily="34" charset="0"/>
+                <a:ea typeface="Calibri" pitchFamily="34" charset="-122"/>
+                <a:cs typeface="Calibri" pitchFamily="34" charset="-120"/>
+              </a:rPr>
+              <a:t>Live Demonstration — the Interactive Pages</a:t>
+            </a:r>
+            <a:endParaRPr lang="en-US" sz="2800" dirty="0"/>
+          </a:p>
+        </p:txBody>
+      </p:sp>
+      <p:pic>
+        <p:nvPicPr>
+          <p:cNvPr id="4" name="Image 0" descr="logo.png"/>
+          <p:cNvPicPr>
+            <a:picLocks noChangeAspect="1"/>
+          </p:cNvPicPr>
+          <p:nvPr/>
+        </p:nvPicPr>
+        <p:blipFill>
+          <a:blip r:embed="rId2"/>
+          <a:stretch>
+            <a:fillRect/>
+          </a:stretch>
+        </p:blipFill>
+        <p:spPr>
+          <a:xfrm>
+            <a:off x="10362895" y="320040"/>
+            <a:ext cx="1371600" cy="518746"/>
+          </a:xfrm>
+          <a:prstGeom prst="rect">
+            <a:avLst/>
+          </a:prstGeom>
+        </p:spPr>
+      </p:pic>
+      <p:pic>
+        <p:nvPicPr>
+          <p:cNvPr id="5" name="Picture 4" descr="portal-crawl.png"/>
+          <p:cNvPicPr>
+            <a:picLocks noChangeAspect="1"/>
+          </p:cNvPicPr>
+          <p:nvPr/>
+        </p:nvPicPr>
+        <p:blipFill>
+          <a:blip r:embed="rId3"/>
+          <a:stretch>
+            <a:fillRect/>
+          </a:stretch>
+        </p:blipFill>
+        <p:spPr>
+          <a:xfrm>
+            <a:off x="548640" y="1543049"/>
+            <a:ext cx="5440680" cy="1520190"/>
+          </a:xfrm>
+          <a:prstGeom prst="rect">
+            <a:avLst/>
+          </a:prstGeom>
+          <a:ln w="6350">
+            <a:solidFill>
+              <a:srgbClr val="808080"/>
+            </a:solidFill>
+          </a:ln>
+        </p:spPr>
+      </p:pic>
+      <p:sp>
+        <p:nvSpPr>
+          <p:cNvPr id="6" name="TextBox 5"/>
+          <p:cNvSpPr txBox="1"/>
+          <p:nvPr/>
+        </p:nvSpPr>
+        <p:spPr>
+          <a:xfrm>
+            <a:off x="548640" y="3099815"/>
+            <a:ext cx="5440680" cy="566928"/>
+          </a:xfrm>
+          <a:prstGeom prst="rect">
+            <a:avLst/>
+          </a:prstGeom>
+          <a:noFill/>
+        </p:spPr>
+        <p:txBody>
+          <a:bodyPr wrap="square">
+            <a:spAutoFit/>
+          </a:bodyPr>
+          <a:lstStyle/>
+          <a:p>
+            <a:r>
+              <a:rPr sz="1000" b="1">
+                <a:solidFill>
+                  <a:srgbClr val="1D2F82"/>
+                </a:solidFill>
+                <a:latin typeface="Calibri"/>
+              </a:rPr>
+              <a:t>1 · The portal run</a:t>
+            </a:r>
+            <a:r>
+              <a:rPr sz="1000"/>
+              <a:t>  —  Every page each technique loaded, replayed on a map of the portal: ours 32, the AI agent 35, the baseline 440 — each total checked against the meter.</a:t>
+            </a:r>
+            <a:r>
+              <a:rPr sz="900">
+                <a:solidFill>
+                  <a:srgbClr val="808080"/>
+                </a:solidFill>
+              </a:rPr>
+              <a:t>  [portal-run.html]</a:t>
+            </a:r>
+          </a:p>
+        </p:txBody>
+      </p:sp>
+      <p:pic>
+        <p:nvPicPr>
+          <p:cNvPr id="7" name="Picture 6" descr="dataset-patient.png"/>
+          <p:cNvPicPr>
+            <a:picLocks noChangeAspect="1"/>
+          </p:cNvPicPr>
+          <p:nvPr/>
+        </p:nvPicPr>
+        <p:blipFill>
+          <a:blip r:embed="rId4"/>
+          <a:stretch>
+            <a:fillRect/>
+          </a:stretch>
+        </p:blipFill>
+        <p:spPr>
+          <a:xfrm>
+            <a:off x="6851536" y="1188719"/>
+            <a:ext cx="4136871" cy="1874519"/>
+          </a:xfrm>
+          <a:prstGeom prst="rect">
+            <a:avLst/>
+          </a:prstGeom>
+          <a:ln w="6350">
+            <a:solidFill>
+              <a:srgbClr val="808080"/>
+            </a:solidFill>
+          </a:ln>
+        </p:spPr>
+      </p:pic>
+      <p:sp>
+        <p:nvSpPr>
+          <p:cNvPr id="8" name="TextBox 7"/>
+          <p:cNvSpPr txBox="1"/>
+          <p:nvPr/>
+        </p:nvSpPr>
+        <p:spPr>
+          <a:xfrm>
+            <a:off x="6199632" y="3099815"/>
+            <a:ext cx="5440680" cy="566928"/>
+          </a:xfrm>
+          <a:prstGeom prst="rect">
+            <a:avLst/>
+          </a:prstGeom>
+          <a:noFill/>
+        </p:spPr>
+        <p:txBody>
+          <a:bodyPr wrap="square">
+            <a:spAutoFit/>
+          </a:bodyPr>
+          <a:lstStyle/>
+          <a:p>
+            <a:r>
+              <a:rPr sz="1000" b="1">
+                <a:solidFill>
+                  <a:srgbClr val="1D2F82"/>
+                </a:solidFill>
+                <a:latin typeface="Calibri"/>
+              </a:rPr>
+              <a:t>2 · An export we never saw</a:t>
+            </a:r>
+            <a:r>
+              <a:rPr sz="1000"/>
+              <a:t>  —  Synthea's public sample, one patient's bill: the agent takes the diagnosis; ours takes three fields; the baseline reads 180,570 records.</a:t>
+            </a:r>
+            <a:r>
+              <a:rPr sz="900">
+                <a:solidFill>
+                  <a:srgbClr val="808080"/>
+                </a:solidFill>
+              </a:rPr>
+              <a:t>  [dataset-walkthrough.html]</a:t>
+            </a:r>
+          </a:p>
+        </p:txBody>
+      </p:sp>
+      <p:pic>
+        <p:nvPicPr>
+          <p:cNvPr id="9" name="Picture 8" descr="assistant-refusal.png"/>
+          <p:cNvPicPr>
+            <a:picLocks noChangeAspect="1"/>
+          </p:cNvPicPr>
+          <p:nvPr/>
+        </p:nvPicPr>
+        <p:blipFill>
+          <a:blip r:embed="rId5"/>
+          <a:stretch>
+            <a:fillRect/>
+          </a:stretch>
+        </p:blipFill>
+        <p:spPr>
+          <a:xfrm>
+            <a:off x="725990" y="3675888"/>
+            <a:ext cx="5085979" cy="1874519"/>
+          </a:xfrm>
+          <a:prstGeom prst="rect">
+            <a:avLst/>
+          </a:prstGeom>
+          <a:ln w="6350">
+            <a:solidFill>
+              <a:srgbClr val="808080"/>
+            </a:solidFill>
+          </a:ln>
+        </p:spPr>
+      </p:pic>
+      <p:sp>
+        <p:nvSpPr>
+          <p:cNvPr id="10" name="TextBox 9"/>
+          <p:cNvSpPr txBox="1"/>
+          <p:nvPr/>
+        </p:nvSpPr>
+        <p:spPr>
+          <a:xfrm>
+            <a:off x="548640" y="5586984"/>
+            <a:ext cx="5440680" cy="566928"/>
+          </a:xfrm>
+          <a:prstGeom prst="rect">
+            <a:avLst/>
+          </a:prstGeom>
+          <a:noFill/>
+        </p:spPr>
+        <p:txBody>
+          <a:bodyPr wrap="square">
+            <a:spAutoFit/>
+          </a:bodyPr>
+          <a:lstStyle/>
+          <a:p>
+            <a:r>
+              <a:rPr sz="1000" b="1">
+                <a:solidFill>
+                  <a:srgbClr val="1D2F82"/>
+                </a:solidFill>
+                <a:latin typeface="Calibri"/>
+              </a:rPr>
+              <a:t>3 · Ask the assistant</a:t>
+            </a:r>
+            <a:r>
+              <a:rPr sz="1000"/>
+              <a:t>  —  The panel types; reception asking for a diagnosis is refused before any detail is asked, with the three checks shown. Verified against the Python assistant on load.</a:t>
+            </a:r>
+            <a:r>
+              <a:rPr sz="900">
+                <a:solidFill>
+                  <a:srgbClr val="808080"/>
+                </a:solidFill>
+              </a:rPr>
+              <a:t>  [assistant.html]</a:t>
+            </a:r>
+          </a:p>
+        </p:txBody>
+      </p:sp>
+      <p:pic>
+        <p:nvPicPr>
+          <p:cNvPr id="11" name="Picture 10" descr="rules-vs-ai.png"/>
+          <p:cNvPicPr>
+            <a:picLocks noChangeAspect="1"/>
+          </p:cNvPicPr>
+          <p:nvPr/>
+        </p:nvPicPr>
+        <p:blipFill>
+          <a:blip r:embed="rId6"/>
+          <a:stretch>
+            <a:fillRect/>
+          </a:stretch>
+        </p:blipFill>
+        <p:spPr>
+          <a:xfrm>
+            <a:off x="7045452" y="3675888"/>
+            <a:ext cx="3749039" cy="1874519"/>
+          </a:xfrm>
+          <a:prstGeom prst="rect">
+            <a:avLst/>
+          </a:prstGeom>
+          <a:ln w="6350">
+            <a:solidFill>
+              <a:srgbClr val="808080"/>
+            </a:solidFill>
+          </a:ln>
+        </p:spPr>
+      </p:pic>
+      <p:sp>
+        <p:nvSpPr>
+          <p:cNvPr id="12" name="TextBox 11"/>
+          <p:cNvSpPr txBox="1"/>
+          <p:nvPr/>
+        </p:nvSpPr>
+        <p:spPr>
+          <a:xfrm>
+            <a:off x="6199632" y="5586984"/>
+            <a:ext cx="5440680" cy="566928"/>
+          </a:xfrm>
+          <a:prstGeom prst="rect">
+            <a:avLst/>
+          </a:prstGeom>
+          <a:noFill/>
+        </p:spPr>
+        <p:txBody>
+          <a:bodyPr wrap="square">
+            <a:spAutoFit/>
+          </a:bodyPr>
+          <a:lstStyle/>
+          <a:p>
+            <a:r>
+              <a:rPr sz="1000" b="1">
+                <a:solidFill>
+                  <a:srgbClr val="1D2F82"/>
+                </a:solidFill>
+                <a:latin typeface="Calibri"/>
+              </a:rPr>
+              <a:t>4 · Rules vs just AI</a:t>
+            </a:r>
+            <a:r>
+              <a:rPr sz="1000"/>
+              <a:t>  —  Eight tasks, five repeats, every repeat scored: close on the score, apart on traps, coverage, minimisation and repeatability.</a:t>
+            </a:r>
+            <a:r>
+              <a:rPr sz="900">
+                <a:solidFill>
+                  <a:srgbClr val="808080"/>
+                </a:solidFill>
+              </a:rPr>
+              <a:t>  [rules-vs-just-ai.html]</a:t>
+            </a:r>
+          </a:p>
+        </p:txBody>
+      </p:sp>
+      <p:sp>
+        <p:nvSpPr>
+          <p:cNvPr id="13" name="TextBox 12"/>
+          <p:cNvSpPr txBox="1"/>
+          <p:nvPr/>
+        </p:nvSpPr>
+        <p:spPr>
+          <a:xfrm>
+            <a:off x="548640" y="6199632"/>
+            <a:ext cx="11064240" cy="320040"/>
+          </a:xfrm>
+          <a:prstGeom prst="rect">
+            <a:avLst/>
+          </a:prstGeom>
+          <a:noFill/>
+        </p:spPr>
+        <p:txBody>
+          <a:bodyPr wrap="square">
+            <a:spAutoFit/>
+          </a:bodyPr>
+          <a:lstStyle/>
+          <a:p>
+            <a:r>
+              <a:rPr sz="1050" b="0">
+                <a:solidFill>
+                  <a:srgbClr val="1D2F82"/>
+                </a:solidFill>
+                <a:latin typeface="Calibri"/>
+              </a:rPr>
+              <a:t>Open docs/review/index.html — every page is offline, built from a real run of the pipeline (tools/build_review_pages.py), and shows no raw patient identifier.</a:t>
             </a:r>
           </a:p>
         </p:txBody>
@@ -14048,7 +14503,7 @@
                 <a:ea typeface="Calibri" pitchFamily="34" charset="-122"/>
                 <a:cs typeface="Calibri" pitchFamily="34" charset="-120"/>
               </a:rPr>
-              <a:t>Modules developed and integrated (src/, 274 tests, CI diffs the regenerated benchmark):</a:t>
+              <a:t>Modules developed and integrated (src/, 300 tests, CI diffs the regenerated benchmark):</a:t>
             </a:r>
             <a:endParaRPr lang="en-US" sz="1500" dirty="0"/>
           </a:p>
@@ -14090,7 +14545,7 @@
                 <a:ea typeface="Calibri" pitchFamily="34" charset="-122"/>
                 <a:cs typeface="Calibri" pitchFamily="34" charset="-120"/>
               </a:rPr>
-              <a:t>extraction/ — HISDataSource interface (transport observed, where= for one patient); adapters mock / portal (Playwright over TLS; search box) / dataset (CSV + Excel, column map, per-file overrides, day-first dates); techniques compliant / ai_agent (one agent = model × briefing; recorded, replayed, rationed) / unconstrained; metering (fields, fetches, pages, records); tier2 browser + navigation discovery.</a:t>
+              <a:t>extraction/ — HISDataSource interface (transport observed, where= for one patient); adapters mock / portal (Playwright over TLS; search box) / dataset (CSV + Excel, column map, per-file overrides, day-first dates, values kept as text, per-concept files stacked); techniques compliant / ai_agent (one agent = model × briefing; recorded, replayed, rationed) / unconstrained; metering (fields, fetches, pages, records); tier2 browser + navigation discovery.</a:t>
             </a:r>
             <a:endParaRPr lang="en-US" sz="1500" dirty="0"/>
           </a:p>
@@ -14111,7 +14566,7 @@
                 <a:ea typeface="Calibri" pitchFamily="34" charset="-122"/>
                 <a:cs typeface="Calibri" pitchFamily="34" charset="-120"/>
               </a:rPr>
-              <a:t>interop/ — HL7 v2 (ADT, ORM, ORU, DFT) and FHIR R4 (12 resources incl. AuditEvent) shapers; normalise + export audit. agent/ — 13-function registry, session state machine, grounded guidance. tools/mock_portal — the Flask fixture built as a system we do not control. scripts/rehearse_day_one.py — the real-data procedure rehearsed on a hospital-shaped export, with a leak audit.</a:t>
+              <a:t>interop/ — HL7 v2 (ADT, ORM, ORU, DFT) and FHIR R4 (12 resources incl. AuditEvent) shapers; normalise + export audit. agent/ — 13-function registry, session state machine, grounded guidance. tools/mock_portal — the Flask fixture built as a system we do not control. scripts/rehearse_day_one.py — the real-data procedure rehearsed on a hospital-shaped export, with a leak audit. tools/build_review_pages.py — four offline demo pages built from real runs.</a:t>
             </a:r>
             <a:endParaRPr lang="en-US" sz="1500" dirty="0"/>
           </a:p>
@@ -14324,7 +14779,7 @@
                 <a:ea typeface="Calibri" pitchFamily="34" charset="-122"/>
                 <a:cs typeface="Calibri" pitchFamily="34" charset="-120"/>
               </a:rPr>
-              <a:t>10</a:t>
+              <a:t>11</a:t>
             </a:r>
             <a:endParaRPr lang="en-US" sz="1000" dirty="0"/>
           </a:p>
@@ -14926,7 +15381,7 @@
                 <a:ea typeface="Calibri" pitchFamily="34" charset="-122"/>
                 <a:cs typeface="Calibri" pitchFamily="34" charset="-120"/>
               </a:rPr>
-              <a:t>11</a:t>
+              <a:t>12</a:t>
             </a:r>
             <a:endParaRPr lang="en-US" sz="1000" dirty="0"/>
           </a:p>

</xml_diff>